<commit_message>
Add photos to New Horizons slideshow
Co-Authored-By: Claude Sonnet 5.5 <noreply@anthropic.com>
Claude-Session: https://claude.ai/code/session_01JhVTk9wF7YCEo1sTZXd1na
</commit_message>
<xml_diff>
--- a/NewHorizons_Unmanned_Systems.pptx
+++ b/NewHorizons_Unmanned_Systems.pptx
@@ -112,28 +112,28 @@
   <p:extLst>
     <p:ext uri="{521415D9-36F7-43E2-AB2F-B90AF26B5E84}">
       <p14:sectionLst xmlns:p14="http://schemas.microsoft.com/office/powerpoint/2010/main">
-        <p14:section name="Introduction" id="{b4886ef4-657c-a64a-0dd2-795325cfee4b}">
+        <p14:section name="Introduction" id="{33aa91da-1d4d-2133-62a0-261b64320139}">
           <p14:sldIdLst>
             <p14:sldId id="256"/>
             <p14:sldId id="257"/>
           </p14:sldIdLst>
         </p14:section>
-        <p14:section name="Background" id="{955d4813-db64-f3b8-b808-b0f9e01aff53}">
+        <p14:section name="Background" id="{1525f9c4-ba55-cc15-e542-827462085d82}">
           <p14:sldIdLst>
             <p14:sldId id="258"/>
           </p14:sldIdLst>
         </p14:section>
-        <p14:section name="The spacecraft" id="{3ac1e166-ef6f-3782-d275-33518471c0c9}">
+        <p14:section name="The spacecraft" id="{d917ea9b-963b-429d-bc29-9fdf9edb3521}">
           <p14:sldIdLst>
             <p14:sldId id="259"/>
           </p14:sldIdLst>
         </p14:section>
-        <p14:section name="The journey" id="{85efd33f-5a82-3542-06c4-0bd6456d12d8}">
+        <p14:section name="The journey" id="{6bca9bf3-96b1-e6bb-9f9f-311a824ac865}">
           <p14:sldIdLst>
             <p14:sldId id="260"/>
           </p14:sldIdLst>
         </p14:section>
-        <p14:section name="Conclusion" id="{329796d5-5009-ad34-8cac-7d8550158359}">
+        <p14:section name="Conclusion" id="{b619d905-4535-dfac-91ce-5c92dc16b2b3}">
           <p14:sldIdLst>
             <p14:sldId id="261"/>
           </p14:sldIdLst>
@@ -1889,72 +1889,33 @@
           <a:chExt cx="0" cy="0"/>
         </a:xfrm>
       </p:grpSpPr>
-      <p:sp>
-        <p:nvSpPr>
-          <p:cNvPr id="2" name="Photo frame"/>
-          <p:cNvSpPr/>
-          <p:nvPr/>
-        </p:nvSpPr>
+      <p:pic>
+        <p:nvPicPr>
+          <p:cNvPr id="2" name="Image 0" descr="Pluto in enhanced color, from New Horizons data">    </p:cNvPr>
+          <p:cNvPicPr>
+            <a:picLocks noChangeAspect="1"/>
+          </p:cNvPicPr>
+          <p:nvPr/>
+        </p:nvPicPr>
+        <p:blipFill>
+          <a:blip r:embed="rId1"/>
+          <a:stretch>
+            <a:fillRect/>
+          </a:stretch>
+        </p:blipFill>
         <p:spPr>
           <a:xfrm>
             <a:off x="5212080" y="548640"/>
             <a:ext cx="3474720" cy="3566160"/>
           </a:xfrm>
-          <a:prstGeom prst="roundRect">
-            <a:avLst>
-              <a:gd name="adj" fmla="val 2105"/>
-            </a:avLst>
-          </a:prstGeom>
-          <a:solidFill>
-            <a:schemeClr val="bg2"/>
-          </a:solidFill>
-          <a:ln w="15875">
-            <a:solidFill>
-              <a:srgbClr val="A9B8D6"/>
-            </a:solidFill>
-            <a:prstDash val="dash"/>
-          </a:ln>
-        </p:spPr>
-      </p:sp>
-      <p:sp>
-        <p:nvSpPr>
-          <p:cNvPr id="3" name="Text 1"/>
-          <p:cNvSpPr txBox="1"/>
-          <p:nvPr/>
-        </p:nvSpPr>
-        <p:spPr>
-          <a:xfrm>
-            <a:off x="5394960" y="548640"/>
-            <a:ext cx="3108960" cy="3566160"/>
-          </a:xfrm>
-          <a:prstGeom prst="rect">
-            <a:avLst/>
-          </a:prstGeom>
-          <a:noFill/>
-          <a:ln/>
-        </p:spPr>
-        <p:txBody>
-          <a:bodyPr wrap="square" lIns="0" tIns="0" rIns="0" bIns="0" rtlCol="0" anchor="ctr"/>
-          <a:lstStyle/>
-          <a:p>
-            <a:pPr algn="ctr" indent="0" marL="0">
-              <a:buNone/>
-            </a:pPr>
-            <a:r>
-              <a:rPr lang="en-US" sz="1300" i="1" dirty="0">
-                <a:solidFill>
-                  <a:schemeClr val="tx2"/>
-                </a:solidFill>
-              </a:rPr>
-              <a:t>Photo: Pluto in true color (NASA)</a:t>
-            </a:r>
-            <a:endParaRPr lang="en-US" sz="1300" dirty="0"/>
-          </a:p>
-        </p:txBody>
-      </p:sp>
-      <p:sp>
-        <p:nvSpPr>
-          <p:cNvPr id="4" name="Text 2"/>
+          <a:prstGeom prst="rect">
+            <a:avLst/>
+          </a:prstGeom>
+        </p:spPr>
+      </p:pic>
+      <p:sp>
+        <p:nvSpPr>
+          <p:cNvPr id="3" name="Text 0"/>
           <p:cNvSpPr txBox="1"/>
           <p:nvPr/>
         </p:nvSpPr>
@@ -1982,7 +1943,7 @@
                   <a:schemeClr val="tx2"/>
                 </a:solidFill>
               </a:rPr>
-              <a:t>Pluto, July 2015. Credit: NASA/JHUAPL/SwRI</a:t>
+              <a:t>Pluto in enhanced color (New Horizons data)</a:t>
             </a:r>
             <a:endParaRPr lang="en-US" sz="1200" dirty="0"/>
           </a:p>
@@ -1990,7 +1951,7 @@
       </p:sp>
       <p:sp>
         <p:nvSpPr>
-          <p:cNvPr id="5" name="Text 0"/>
+          <p:cNvPr id="4" name="Text 0"/>
           <p:cNvSpPr/>
           <p:nvPr>
             <p:ph idx="100" type="title" hasCustomPrompt="1"/>
@@ -2028,7 +1989,7 @@
       </p:sp>
       <p:sp>
         <p:nvSpPr>
-          <p:cNvPr id="6" name="Text 0"/>
+          <p:cNvPr id="5" name="Text 0"/>
           <p:cNvSpPr/>
           <p:nvPr>
             <p:ph idx="101" type="body" hasCustomPrompt="1"/>
@@ -2066,7 +2027,7 @@
       </p:sp>
       <p:sp>
         <p:nvSpPr>
-          <p:cNvPr id="7" name="Text 5"/>
+          <p:cNvPr id="6" name="Text 3"/>
           <p:cNvSpPr txBox="1"/>
           <p:nvPr/>
         </p:nvSpPr>
@@ -4313,72 +4274,33 @@
           </a:p>
         </p:txBody>
       </p:sp>
-      <p:sp>
-        <p:nvSpPr>
-          <p:cNvPr id="4" name="Photo frame"/>
-          <p:cNvSpPr/>
-          <p:nvPr/>
-        </p:nvSpPr>
-        <p:spPr>
-          <a:xfrm>
-            <a:off x="457200" y="1600200"/>
-            <a:ext cx="3566160" cy="2697480"/>
-          </a:xfrm>
-          <a:prstGeom prst="roundRect">
-            <a:avLst>
-              <a:gd name="adj" fmla="val 2712"/>
-            </a:avLst>
-          </a:prstGeom>
-          <a:solidFill>
-            <a:schemeClr val="bg2"/>
-          </a:solidFill>
-          <a:ln w="15875">
-            <a:solidFill>
-              <a:srgbClr val="A9B8D6"/>
-            </a:solidFill>
-            <a:prstDash val="dash"/>
-          </a:ln>
-        </p:spPr>
-      </p:sp>
-      <p:sp>
-        <p:nvSpPr>
-          <p:cNvPr id="5" name="Text 3"/>
-          <p:cNvSpPr txBox="1"/>
-          <p:nvPr/>
-        </p:nvSpPr>
-        <p:spPr>
-          <a:xfrm>
-            <a:off x="640080" y="1600200"/>
-            <a:ext cx="3200400" cy="2697480"/>
-          </a:xfrm>
-          <a:prstGeom prst="rect">
-            <a:avLst/>
-          </a:prstGeom>
-          <a:noFill/>
-          <a:ln/>
-        </p:spPr>
-        <p:txBody>
-          <a:bodyPr wrap="square" lIns="0" tIns="0" rIns="0" bIns="0" rtlCol="0" anchor="ctr"/>
-          <a:lstStyle/>
-          <a:p>
-            <a:pPr algn="ctr" indent="0" marL="0">
-              <a:buNone/>
-            </a:pPr>
-            <a:r>
-              <a:rPr lang="en-US" sz="1300" i="1" dirty="0">
-                <a:solidFill>
-                  <a:schemeClr val="tx2"/>
-                </a:solidFill>
-              </a:rPr>
-              <a:t>Photo: New Horizons spacecraft (NASA)</a:t>
-            </a:r>
-            <a:endParaRPr lang="en-US" sz="1300" dirty="0"/>
-          </a:p>
-        </p:txBody>
-      </p:sp>
-      <p:sp>
-        <p:nvSpPr>
-          <p:cNvPr id="6" name="Text 4"/>
+      <p:pic>
+        <p:nvPicPr>
+          <p:cNvPr id="4" name="Image 0" descr="Artist concept of the New Horizons spacecraft near Pluto and its moon Charon">    </p:cNvPr>
+          <p:cNvPicPr>
+            <a:picLocks noChangeAspect="1"/>
+          </p:cNvPicPr>
+          <p:nvPr/>
+        </p:nvPicPr>
+        <p:blipFill>
+          <a:blip r:embed="rId1"/>
+          <a:stretch>
+            <a:fillRect/>
+          </a:stretch>
+        </p:blipFill>
+        <p:spPr>
+          <a:xfrm>
+            <a:off x="914400" y="1600200"/>
+            <a:ext cx="2176272" cy="2697480"/>
+          </a:xfrm>
+          <a:prstGeom prst="rect">
+            <a:avLst/>
+          </a:prstGeom>
+        </p:spPr>
+      </p:pic>
+      <p:sp>
+        <p:nvSpPr>
+          <p:cNvPr id="5" name="Text 2"/>
           <p:cNvSpPr txBox="1"/>
           <p:nvPr/>
         </p:nvSpPr>
@@ -4406,7 +4328,7 @@
                   <a:schemeClr val="tx2"/>
                 </a:solidFill>
               </a:rPr>
-              <a:t>New Horizons before launch. Credit: NASA/JHUAPL</a:t>
+              <a:t>Artist's concept: New Horizons at Pluto and Charon</a:t>
             </a:r>
             <a:endParaRPr lang="en-US" sz="1200" dirty="0"/>
           </a:p>
@@ -4414,7 +4336,7 @@
       </p:sp>
       <p:sp>
         <p:nvSpPr>
-          <p:cNvPr id="7" name="Spacecraft card"/>
+          <p:cNvPr id="6" name="Spacecraft card"/>
           <p:cNvSpPr/>
           <p:nvPr/>
         </p:nvSpPr>
@@ -4441,7 +4363,7 @@
       </p:sp>
       <p:sp>
         <p:nvSpPr>
-          <p:cNvPr id="8" name="Icon badge"/>
+          <p:cNvPr id="7" name="Icon badge"/>
           <p:cNvSpPr/>
           <p:nvPr/>
         </p:nvSpPr>
@@ -4466,14 +4388,14 @@
       </p:sp>
       <p:pic>
         <p:nvPicPr>
-          <p:cNvPr id="9" name="Image 0" descr="icon">    </p:cNvPr>
+          <p:cNvPr id="8" name="Image 1" descr="icon">    </p:cNvPr>
           <p:cNvPicPr>
             <a:picLocks noChangeAspect="1"/>
           </p:cNvPicPr>
           <p:nvPr/>
         </p:nvPicPr>
         <p:blipFill>
-          <a:blip r:embed="rId1"/>
+          <a:blip r:embed="rId2"/>
           <a:stretch>
             <a:fillRect/>
           </a:stretch>
@@ -4490,7 +4412,7 @@
       </p:pic>
       <p:sp>
         <p:nvSpPr>
-          <p:cNvPr id="10" name="Text 7"/>
+          <p:cNvPr id="9" name="Text 5"/>
           <p:cNvSpPr txBox="1"/>
           <p:nvPr/>
         </p:nvSpPr>
@@ -4526,7 +4448,7 @@
       </p:sp>
       <p:sp>
         <p:nvSpPr>
-          <p:cNvPr id="11" name="Text 8"/>
+          <p:cNvPr id="10" name="Text 6"/>
           <p:cNvSpPr txBox="1"/>
           <p:nvPr/>
         </p:nvSpPr>
@@ -4562,7 +4484,7 @@
       </p:sp>
       <p:sp>
         <p:nvSpPr>
-          <p:cNvPr id="12" name="Spacecraft card"/>
+          <p:cNvPr id="11" name="Spacecraft card"/>
           <p:cNvSpPr/>
           <p:nvPr/>
         </p:nvSpPr>
@@ -4589,7 +4511,7 @@
       </p:sp>
       <p:sp>
         <p:nvSpPr>
-          <p:cNvPr id="13" name="Icon badge"/>
+          <p:cNvPr id="12" name="Icon badge"/>
           <p:cNvSpPr/>
           <p:nvPr/>
         </p:nvSpPr>
@@ -4614,14 +4536,14 @@
       </p:sp>
       <p:pic>
         <p:nvPicPr>
-          <p:cNvPr id="14" name="Image 1" descr="icon">    </p:cNvPr>
+          <p:cNvPr id="13" name="Image 2" descr="icon">    </p:cNvPr>
           <p:cNvPicPr>
             <a:picLocks noChangeAspect="1"/>
           </p:cNvPicPr>
           <p:nvPr/>
         </p:nvPicPr>
         <p:blipFill>
-          <a:blip r:embed="rId2"/>
+          <a:blip r:embed="rId3"/>
           <a:stretch>
             <a:fillRect/>
           </a:stretch>
@@ -4638,7 +4560,7 @@
       </p:pic>
       <p:sp>
         <p:nvSpPr>
-          <p:cNvPr id="15" name="Text 11"/>
+          <p:cNvPr id="14" name="Text 9"/>
           <p:cNvSpPr txBox="1"/>
           <p:nvPr/>
         </p:nvSpPr>
@@ -4674,7 +4596,7 @@
       </p:sp>
       <p:sp>
         <p:nvSpPr>
-          <p:cNvPr id="16" name="Text 12"/>
+          <p:cNvPr id="15" name="Text 10"/>
           <p:cNvSpPr txBox="1"/>
           <p:nvPr/>
         </p:nvSpPr>
@@ -4710,7 +4632,7 @@
       </p:sp>
       <p:sp>
         <p:nvSpPr>
-          <p:cNvPr id="17" name="Spacecraft card"/>
+          <p:cNvPr id="16" name="Spacecraft card"/>
           <p:cNvSpPr/>
           <p:nvPr/>
         </p:nvSpPr>
@@ -4737,7 +4659,7 @@
       </p:sp>
       <p:sp>
         <p:nvSpPr>
-          <p:cNvPr id="18" name="Icon badge"/>
+          <p:cNvPr id="17" name="Icon badge"/>
           <p:cNvSpPr/>
           <p:nvPr/>
         </p:nvSpPr>
@@ -4762,14 +4684,14 @@
       </p:sp>
       <p:pic>
         <p:nvPicPr>
-          <p:cNvPr id="19" name="Image 2" descr="icon">    </p:cNvPr>
+          <p:cNvPr id="18" name="Image 3" descr="icon">    </p:cNvPr>
           <p:cNvPicPr>
             <a:picLocks noChangeAspect="1"/>
           </p:cNvPicPr>
           <p:nvPr/>
         </p:nvPicPr>
         <p:blipFill>
-          <a:blip r:embed="rId3"/>
+          <a:blip r:embed="rId4"/>
           <a:stretch>
             <a:fillRect/>
           </a:stretch>
@@ -4786,7 +4708,7 @@
       </p:pic>
       <p:sp>
         <p:nvSpPr>
-          <p:cNvPr id="20" name="Text 15"/>
+          <p:cNvPr id="19" name="Text 13"/>
           <p:cNvSpPr txBox="1"/>
           <p:nvPr/>
         </p:nvSpPr>
@@ -4822,7 +4744,7 @@
       </p:sp>
       <p:sp>
         <p:nvSpPr>
-          <p:cNvPr id="21" name="Text 16"/>
+          <p:cNvPr id="20" name="Text 14"/>
           <p:cNvSpPr txBox="1"/>
           <p:nvPr/>
         </p:nvSpPr>
@@ -5016,72 +4938,33 @@
           </a:graphicData>
         </a:graphic>
       </p:graphicFrame>
-      <p:sp>
-        <p:nvSpPr>
-          <p:cNvPr id="5" name="Photo frame"/>
-          <p:cNvSpPr/>
-          <p:nvPr/>
-        </p:nvSpPr>
+      <p:pic>
+        <p:nvPicPr>
+          <p:cNvPr id="5" name="Image 0" descr="Illustration of Pluto's heart-shaped icy plain">    </p:cNvPr>
+          <p:cNvPicPr>
+            <a:picLocks noChangeAspect="1"/>
+          </p:cNvPicPr>
+          <p:nvPr/>
+        </p:nvPicPr>
+        <p:blipFill>
+          <a:blip r:embed="rId2"/>
+          <a:stretch>
+            <a:fillRect/>
+          </a:stretch>
+        </p:blipFill>
         <p:spPr>
           <a:xfrm>
             <a:off x="4572000" y="1600200"/>
             <a:ext cx="4114800" cy="1965960"/>
           </a:xfrm>
-          <a:prstGeom prst="roundRect">
-            <a:avLst>
-              <a:gd name="adj" fmla="val 3721"/>
-            </a:avLst>
-          </a:prstGeom>
-          <a:solidFill>
-            <a:schemeClr val="bg2"/>
-          </a:solidFill>
-          <a:ln w="15875">
-            <a:solidFill>
-              <a:srgbClr val="A9B8D6"/>
-            </a:solidFill>
-            <a:prstDash val="dash"/>
-          </a:ln>
-        </p:spPr>
-      </p:sp>
-      <p:sp>
-        <p:nvSpPr>
-          <p:cNvPr id="6" name="Text 3"/>
-          <p:cNvSpPr txBox="1"/>
-          <p:nvPr/>
-        </p:nvSpPr>
-        <p:spPr>
-          <a:xfrm>
-            <a:off x="4754880" y="1600200"/>
-            <a:ext cx="3749040" cy="1965960"/>
-          </a:xfrm>
-          <a:prstGeom prst="rect">
-            <a:avLst/>
-          </a:prstGeom>
-          <a:noFill/>
-          <a:ln/>
-        </p:spPr>
-        <p:txBody>
-          <a:bodyPr wrap="square" lIns="0" tIns="0" rIns="0" bIns="0" rtlCol="0" anchor="ctr"/>
-          <a:lstStyle/>
-          <a:p>
-            <a:pPr algn="ctr" indent="0" marL="0">
-              <a:buNone/>
-            </a:pPr>
-            <a:r>
-              <a:rPr lang="en-US" sz="1300" i="1" dirty="0">
-                <a:solidFill>
-                  <a:schemeClr val="tx2"/>
-                </a:solidFill>
-              </a:rPr>
-              <a:t>Photo: Pluto's heart-shaped region (NASA)</a:t>
-            </a:r>
-            <a:endParaRPr lang="en-US" sz="1300" dirty="0"/>
-          </a:p>
-        </p:txBody>
-      </p:sp>
-      <p:sp>
-        <p:nvSpPr>
-          <p:cNvPr id="7" name="Text 4"/>
+          <a:prstGeom prst="rect">
+            <a:avLst/>
+          </a:prstGeom>
+        </p:spPr>
+      </p:pic>
+      <p:sp>
+        <p:nvSpPr>
+          <p:cNvPr id="6" name="Text 2"/>
           <p:cNvSpPr txBox="1"/>
           <p:nvPr/>
         </p:nvSpPr>
@@ -5109,7 +4992,7 @@
                   <a:schemeClr val="tx2"/>
                 </a:solidFill>
               </a:rPr>
-              <a:t>Tombaugh Regio. Credit: NASA/JHUAPL/SwRI</a:t>
+              <a:t>Illustration of Pluto's heart-shaped icy plain</a:t>
             </a:r>
             <a:endParaRPr lang="en-US" sz="1200" dirty="0"/>
           </a:p>
@@ -5117,7 +5000,7 @@
       </p:sp>
       <p:sp>
         <p:nvSpPr>
-          <p:cNvPr id="8" name="Stat chip"/>
+          <p:cNvPr id="7" name="Stat chip"/>
           <p:cNvSpPr/>
           <p:nvPr/>
         </p:nvSpPr>
@@ -5144,7 +5027,7 @@
       </p:sp>
       <p:sp>
         <p:nvSpPr>
-          <p:cNvPr id="9" name="Text 6"/>
+          <p:cNvPr id="8" name="Text 4"/>
           <p:cNvSpPr txBox="1"/>
           <p:nvPr/>
         </p:nvSpPr>
@@ -5180,7 +5063,7 @@
       </p:sp>
       <p:sp>
         <p:nvSpPr>
-          <p:cNvPr id="10" name="Text 7"/>
+          <p:cNvPr id="9" name="Text 5"/>
           <p:cNvSpPr txBox="1"/>
           <p:nvPr/>
         </p:nvSpPr>
@@ -5216,7 +5099,7 @@
       </p:sp>
       <p:sp>
         <p:nvSpPr>
-          <p:cNvPr id="11" name="Stat chip"/>
+          <p:cNvPr id="10" name="Stat chip"/>
           <p:cNvSpPr/>
           <p:nvPr/>
         </p:nvSpPr>
@@ -5243,7 +5126,7 @@
       </p:sp>
       <p:sp>
         <p:nvSpPr>
-          <p:cNvPr id="12" name="Text 9"/>
+          <p:cNvPr id="11" name="Text 7"/>
           <p:cNvSpPr txBox="1"/>
           <p:nvPr/>
         </p:nvSpPr>
@@ -5279,7 +5162,7 @@
       </p:sp>
       <p:sp>
         <p:nvSpPr>
-          <p:cNvPr id="13" name="Text 10"/>
+          <p:cNvPr id="12" name="Text 8"/>
           <p:cNvSpPr txBox="1"/>
           <p:nvPr/>
         </p:nvSpPr>
@@ -5315,7 +5198,7 @@
       </p:sp>
       <p:sp>
         <p:nvSpPr>
-          <p:cNvPr id="14" name="Stat chip"/>
+          <p:cNvPr id="13" name="Stat chip"/>
           <p:cNvSpPr/>
           <p:nvPr/>
         </p:nvSpPr>
@@ -5342,7 +5225,7 @@
       </p:sp>
       <p:sp>
         <p:nvSpPr>
-          <p:cNvPr id="15" name="Text 12"/>
+          <p:cNvPr id="14" name="Text 10"/>
           <p:cNvSpPr txBox="1"/>
           <p:nvPr/>
         </p:nvSpPr>
@@ -5378,7 +5261,7 @@
       </p:sp>
       <p:sp>
         <p:nvSpPr>
-          <p:cNvPr id="16" name="Text 13"/>
+          <p:cNvPr id="15" name="Text 11"/>
           <p:cNvSpPr txBox="1"/>
           <p:nvPr/>
         </p:nvSpPr>

</xml_diff>